<commit_message>
Puerto Fénix rev. 2: enlace de ubicación + firma de captación (D-096)
- Diapositiva 2: hipervínculo de Google Maps en el mapa y en el texto
  "Ver ubicación exacta en Google Maps" (URL corta impresa para lectura
  en papel); hipervínculos con colores de marca en el tema.
- Diapositiva 12: firma "Broker Inmobiliario" como norma para captación de
  propiedades en alquiler + pie institucional "Meridiano Capital ·
  Operadores técnicos y legales de inversiones inmobiliarias".
- D-096 (CURRENT) extiende D-039 y resuelve U-034; Variante C agregada a
  knowledge-base/brand/09-cierres-y-firmas.md.
- PDF, PNG de revisión e informe de validación regenerados.

Co-Authored-By: Claude Opus 5.5 <noreply@anthropic.com>
Claude-Session: https://claude.ai/code/session_017RNMd6JafMiQTsviv1BWoj
</commit_message>
<xml_diff>
--- a/projects/puerto-fenix/entregables/Meridiano_Capital_Puerto_Fenix_Presentacion_Corporativa_Final.pptx
+++ b/projects/puerto-fenix/entregables/Meridiano_Capital_Puerto_Fenix_Presentacion_Corporativa_Final.pptx
@@ -777,7 +777,7 @@
           <a:p>
             <a:r>
               <a:rPr lang="en-US" dirty="0"/>
-              <a:t>Contacto comercial actualizado por el usuario: Juan José Castillo, Broker Inmobiliario, Meridiano Capital, +595 982 853 111, juancastillo@meridianocapital.net. Fotografía profesional incorporada en la versión aprobada, sin retoques. Ver VALIDACION_PRESENTACION_PUERTO_FENIX.md: el cargo «Broker Inmobiliario» difiere de la firma canónica de knowledge-base/brand/09-cierres-y-firmas.md y queda registrado para confirmación.</a:t>
+              <a:t>Contacto comercial actualizado por el usuario: Juan José Castillo, Broker Inmobiliario, Meridiano Capital, +595 982 853 111, juancastillo@meridianocapital.net. Fotografía profesional incorporada en la versión aprobada, sin retoques. Firma «Broker Inmobiliario» = norma vigente cuando Meridiano actúa como captador de propiedades en alquiler (D-096, resuelve U-034), con el pie institucional «Operadores técnicos y legales de inversiones inmobiliarias» al cierre.</a:t>
             </a:r>
             <a:endParaRPr lang="en-US" dirty="0"/>
           </a:p>
@@ -865,7 +865,7 @@
           <a:p>
             <a:r>
               <a:rPr lang="en-US" dirty="0"/>
-              <a:t>Fuente: página 2 y mapa incorporado en el documento adjunto. No se agregaron tiempos de viaje ni distancias no informadas. PENDIENTE: la presentación v7 indicaba conservar el enlace de localización exacta del documento fuente, pero ese enlace no está incluido en el archivo recibido; agregarlo como hipervínculo sobre el mapa cuando se disponga de él.</a:t>
+              <a:t>Fuente: página 2 y mapa incorporado en el documento adjunto. No se agregaron tiempos de viaje ni distancias no informadas. Enlace de ubicación exacta aportado por el founder el 2026-09-25 (https://maps.app.goo.gl/jHo2dQB1tqhid7nAA): vinculado al mapa y al texto «Ver ubicación exacta en Google Maps».</a:t>
             </a:r>
             <a:endParaRPr lang="en-US" dirty="0"/>
           </a:p>
@@ -3612,7 +3612,7 @@
         </p:nvSpPr>
         <p:spPr>
           <a:xfrm>
-            <a:off x="548640" y="1828800"/>
+            <a:off x="548640" y="1645920"/>
             <a:ext cx="6858000" cy="1463040"/>
           </a:xfrm>
           <a:prstGeom prst="rect">
@@ -3674,7 +3674,7 @@
         </p:nvSpPr>
         <p:spPr>
           <a:xfrm>
-            <a:off x="548640" y="3429000"/>
+            <a:off x="548640" y="3200400"/>
             <a:ext cx="6583680" cy="731520"/>
           </a:xfrm>
           <a:prstGeom prst="rect">
@@ -3718,7 +3718,7 @@
         </p:nvSpPr>
         <p:spPr>
           <a:xfrm>
-            <a:off x="548640" y="4434840"/>
+            <a:off x="548640" y="4114800"/>
             <a:ext cx="6720840" cy="0"/>
           </a:xfrm>
           <a:prstGeom prst="line">
@@ -3741,7 +3741,7 @@
         </p:nvSpPr>
         <p:spPr>
           <a:xfrm>
-            <a:off x="548640" y="4617720"/>
+            <a:off x="548640" y="4261104"/>
             <a:ext cx="6766560" cy="457200"/>
           </a:xfrm>
           <a:prstGeom prst="rect">
@@ -3780,7 +3780,7 @@
         </p:nvSpPr>
         <p:spPr>
           <a:xfrm>
-            <a:off x="548640" y="5074920"/>
+            <a:off x="548640" y="4718304"/>
             <a:ext cx="6766560" cy="320040"/>
           </a:xfrm>
           <a:prstGeom prst="rect">
@@ -3819,7 +3819,7 @@
         </p:nvSpPr>
         <p:spPr>
           <a:xfrm>
-            <a:off x="548640" y="5468112"/>
+            <a:off x="548640" y="5084064"/>
             <a:ext cx="6949440" cy="320040"/>
           </a:xfrm>
           <a:prstGeom prst="rect">
@@ -3858,7 +3858,7 @@
         </p:nvSpPr>
         <p:spPr>
           <a:xfrm>
-            <a:off x="548640" y="6053328"/>
+            <a:off x="548640" y="5504688"/>
             <a:ext cx="6858000" cy="457200"/>
           </a:xfrm>
           <a:prstGeom prst="rect">
@@ -3889,6 +3889,68 @@
                 <a:cs typeface="Poppins" pitchFamily="34" charset="-120"/>
               </a:rPr>
               <a:t>Documento comercial de referencia. Valores en USD más IVA según la cotización de Puerto Fénix; las condiciones definitivas se formalizan en el contrato de locación. Oferta válida por 5 días.</a:t>
+            </a:r>
+            <a:endParaRPr lang="en-US" sz="900" dirty="0"/>
+          </a:p>
+        </p:txBody>
+      </p:sp>
+      <p:sp>
+        <p:nvSpPr>
+          <p:cNvPr id="11" name="Shape 7"/>
+          <p:cNvSpPr/>
+          <p:nvPr/>
+        </p:nvSpPr>
+        <p:spPr>
+          <a:xfrm>
+            <a:off x="548640" y="6199632"/>
+            <a:ext cx="6720840" cy="0"/>
+          </a:xfrm>
+          <a:prstGeom prst="line">
+            <a:avLst/>
+          </a:prstGeom>
+          <a:noFill/>
+          <a:ln w="9525">
+            <a:solidFill>
+              <a:srgbClr val="F3EDE3"/>
+            </a:solidFill>
+            <a:prstDash val="solid"/>
+          </a:ln>
+        </p:spPr>
+      </p:sp>
+      <p:sp>
+        <p:nvSpPr>
+          <p:cNvPr id="12" name="Text 8"/>
+          <p:cNvSpPr txBox="1"/>
+          <p:nvPr/>
+        </p:nvSpPr>
+        <p:spPr>
+          <a:xfrm>
+            <a:off x="548640" y="6309360"/>
+            <a:ext cx="7132320" cy="274320"/>
+          </a:xfrm>
+          <a:prstGeom prst="rect">
+            <a:avLst/>
+          </a:prstGeom>
+          <a:noFill/>
+          <a:ln/>
+        </p:spPr>
+        <p:txBody>
+          <a:bodyPr wrap="square" lIns="0" tIns="0" rIns="0" bIns="0" rtlCol="0" anchor="ctr"/>
+          <a:lstStyle/>
+          <a:p>
+            <a:pPr indent="0" marL="0">
+              <a:buNone/>
+            </a:pPr>
+            <a:r>
+              <a:rPr lang="en-US" sz="900" b="1" spc="120" kern="0" dirty="0">
+                <a:solidFill>
+                  <a:srgbClr val="F3EDE3"/>
+                </a:solidFill>
+                <a:latin typeface="Poppins" pitchFamily="34" charset="0"/>
+                <a:ea typeface="Poppins" pitchFamily="34" charset="-122"/>
+                <a:cs typeface="Poppins" pitchFamily="34" charset="-120"/>
+              </a:rPr>
+              <a:t>MERIDIANO CAPITAL  ·  OPERADORES TÉCNICOS Y LEGALES DE INVERSIONES INMOBILIARIAS</a:t>
             </a:r>
             <a:endParaRPr lang="en-US" sz="900" dirty="0"/>
           </a:p>
@@ -4034,7 +4096,9 @@
       </p:sp>
       <p:pic>
         <p:nvPicPr>
-          <p:cNvPr id="5" name="Image 0" descr="Mapa de ubicación: Mariano Roque Alonso en el área metropolitana de Asunción">    </p:cNvPr>
+          <p:cNvPr id="5" name="Image 0" descr="Mapa de ubicación: Mariano Roque Alonso en el área metropolitana de Asunción">
+            <a:hlinkClick r:id="rId2" tooltip="Abrir la ubicación en Google Maps"/>
+          </p:cNvPr>
           <p:cNvPicPr>
             <a:picLocks noChangeAspect="1"/>
           </p:cNvPicPr>
@@ -4246,7 +4310,7 @@
         </p:nvSpPr>
         <p:spPr>
           <a:xfrm>
-            <a:off x="6720840" y="4325112"/>
+            <a:off x="6720840" y="4233672"/>
             <a:ext cx="4922215" cy="0"/>
           </a:xfrm>
           <a:prstGeom prst="line">
@@ -4269,7 +4333,7 @@
         </p:nvSpPr>
         <p:spPr>
           <a:xfrm>
-            <a:off x="6720840" y="4507992"/>
+            <a:off x="6720840" y="4416552"/>
             <a:ext cx="502920" cy="320040"/>
           </a:xfrm>
           <a:prstGeom prst="rect">
@@ -4308,7 +4372,7 @@
         </p:nvSpPr>
         <p:spPr>
           <a:xfrm>
-            <a:off x="7269480" y="4507992"/>
+            <a:off x="7269480" y="4416552"/>
             <a:ext cx="4373575" cy="365760"/>
           </a:xfrm>
           <a:prstGeom prst="rect">
@@ -4347,7 +4411,7 @@
         </p:nvSpPr>
         <p:spPr>
           <a:xfrm>
-            <a:off x="6720840" y="5038344"/>
+            <a:off x="6720840" y="4855464"/>
             <a:ext cx="4922215" cy="0"/>
           </a:xfrm>
           <a:prstGeom prst="line">
@@ -4370,7 +4434,7 @@
         </p:nvSpPr>
         <p:spPr>
           <a:xfrm>
-            <a:off x="6720840" y="5221224"/>
+            <a:off x="6720840" y="5038344"/>
             <a:ext cx="502920" cy="320040"/>
           </a:xfrm>
           <a:prstGeom prst="rect">
@@ -4409,7 +4473,7 @@
         </p:nvSpPr>
         <p:spPr>
           <a:xfrm>
-            <a:off x="7269480" y="5221224"/>
+            <a:off x="7269480" y="5038344"/>
             <a:ext cx="4373575" cy="365760"/>
           </a:xfrm>
           <a:prstGeom prst="rect">
@@ -4448,7 +4512,7 @@
         </p:nvSpPr>
         <p:spPr>
           <a:xfrm>
-            <a:off x="6720840" y="5751576"/>
+            <a:off x="6720840" y="5477256"/>
             <a:ext cx="4922215" cy="0"/>
           </a:xfrm>
           <a:prstGeom prst="line">
@@ -4463,19 +4527,94 @@
           </a:ln>
         </p:spPr>
       </p:sp>
+      <p:sp>
+        <p:nvSpPr>
+          <p:cNvPr id="18" name="Text 15"/>
+          <p:cNvSpPr txBox="1"/>
+          <p:nvPr/>
+        </p:nvSpPr>
+        <p:spPr>
+          <a:xfrm>
+            <a:off x="6720840" y="5669280"/>
+            <a:ext cx="4922215" cy="566928"/>
+          </a:xfrm>
+          <a:prstGeom prst="rect">
+            <a:avLst/>
+          </a:prstGeom>
+          <a:noFill/>
+          <a:ln/>
+        </p:spPr>
+        <p:txBody>
+          <a:bodyPr wrap="square" lIns="0" tIns="0" rIns="0" bIns="0" rtlCol="0" anchor="t"/>
+          <a:lstStyle/>
+          <a:p>
+            <a:pPr indent="0" marL="0">
+              <a:lnSpc>
+                <a:spcPct val="120000"/>
+              </a:lnSpc>
+              <a:buNone/>
+            </a:pPr>
+            <a:r>
+              <a:rPr lang="en-US" sz="1250" b="1" u="sng" dirty="0">
+                <a:solidFill>
+                  <a:srgbClr val="8B3323"/>
+                </a:solidFill>
+                <a:latin typeface="Poppins" pitchFamily="34" charset="0"/>
+                <a:ea typeface="Poppins" pitchFamily="34" charset="-122"/>
+                <a:cs typeface="Poppins" pitchFamily="34" charset="-120"/>
+                <a:hlinkClick r:id="rId3" invalidUrl="" action="" tgtFrame="" tooltip="Abrir la ubicación en Google Maps" history="1" highlightClick="0" endSnd="0">
+                  <a:extLst>
+                    <a:ext uri="{A12FA001-AC4F-418D-AE19-62706E023703}">
+                      <ahyp:hlinkClr xmlns:ahyp="http://schemas.microsoft.com/office/drawing/2018/hyperlinkcolor" val="tx"/>
+                    </a:ext>
+                  </a:extLst>
+                </a:hlinkClick>
+              </a:rPr>
+              <a:t>Ver ubicación exacta en Google Maps</a:t>
+            </a:r>
+            <a:pPr indent="0" marL="0">
+              <a:lnSpc>
+                <a:spcPct val="120000"/>
+              </a:lnSpc>
+              <a:buNone/>
+            </a:pPr>
+            <a:endParaRPr lang="en-US" sz="1250" dirty="0"/>
+          </a:p>
+          <a:p>
+            <a:pPr indent="0" marL="0">
+              <a:lnSpc>
+                <a:spcPct val="120000"/>
+              </a:lnSpc>
+              <a:buNone/>
+            </a:pPr>
+            <a:r>
+              <a:rPr lang="en-US" sz="1050" dirty="0">
+                <a:solidFill>
+                  <a:srgbClr val="6B6154"/>
+                </a:solidFill>
+                <a:latin typeface="Poppins" pitchFamily="34" charset="0"/>
+                <a:ea typeface="Poppins" pitchFamily="34" charset="-122"/>
+                <a:cs typeface="Poppins" pitchFamily="34" charset="-120"/>
+              </a:rPr>
+              <a:t>maps.app.goo.gl/jHo2dQB1tqhid7nAA</a:t>
+            </a:r>
+            <a:endParaRPr lang="en-US" sz="1250" dirty="0"/>
+          </a:p>
+        </p:txBody>
+      </p:sp>
       <p:pic>
         <p:nvPicPr>
-          <p:cNvPr id="18" name="Image 1" descr="Isotipo Meridiano Capital">    </p:cNvPr>
+          <p:cNvPr id="19" name="Image 1" descr="Isotipo Meridiano Capital">    </p:cNvPr>
           <p:cNvPicPr>
             <a:picLocks noChangeAspect="1"/>
           </p:cNvPicPr>
           <p:nvPr/>
         </p:nvPicPr>
         <p:blipFill>
-          <a:blip r:embed="rId2">
+          <a:blip r:embed="rId4">
             <a:extLst>
               <a:ext uri="{96DAC541-7B7A-43D3-8B79-37D633B846F1}">
-                <asvg:svgBlip xmlns:asvg="http://schemas.microsoft.com/office/drawing/2016/SVG/main" r:embed="rId3"/>
+                <asvg:svgBlip xmlns:asvg="http://schemas.microsoft.com/office/drawing/2016/SVG/main" r:embed="rId5"/>
               </a:ext>
             </a:extLst>
           </a:blip>
@@ -4495,7 +4634,7 @@
       </p:pic>
       <p:sp>
         <p:nvSpPr>
-          <p:cNvPr id="19" name="Text 15"/>
+          <p:cNvPr id="20" name="Text 16"/>
           <p:cNvSpPr txBox="1"/>
           <p:nvPr/>
         </p:nvSpPr>
@@ -4534,7 +4673,7 @@
       </p:sp>
       <p:sp>
         <p:nvSpPr>
-          <p:cNvPr id="20" name="Text 16"/>
+          <p:cNvPr id="21" name="Text 17"/>
           <p:cNvSpPr txBox="1"/>
           <p:nvPr/>
         </p:nvSpPr>
@@ -10735,10 +10874,10 @@
         <a:srgbClr val="70AD47"/>
       </a:accent6>
       <a:hlink>
-        <a:srgbClr val="0563C1"/>
+        <a:srgbClr val="8B3323"/>
       </a:hlink>
       <a:folHlink>
-        <a:srgbClr val="954F72"/>
+        <a:srgbClr val="6B6154"/>
       </a:folHlink>
     </a:clrScheme>
     <a:fontScheme name="Office">

</xml_diff>